<commit_message>
docs: condense accented ASR slides
</commit_message>
<xml_diff>
--- a/speech_pretraining_project_discussion_with_accented_speech.pptx
+++ b/speech_pretraining_project_discussion_with_accented_speech.pptx
@@ -4026,7 +4026,7 @@
               </a:defRPr>
             </a:pPr>
             <a:r>
-              <a:t>Accented ASR as a downstream case study</a:t>
+              <a:t>Accented ASR: current setup</a:t>
             </a:r>
           </a:p>
         </p:txBody>
@@ -4112,50 +4112,14 @@
       </p:sp>
       <p:sp>
         <p:nvSpPr>
-          <p:cNvPr id="5" name="TextBox 4"/>
-          <p:cNvSpPr txBox="1"/>
-          <p:nvPr/>
-        </p:nvSpPr>
-        <p:spPr>
-          <a:xfrm>
-            <a:off x="1082040" y="1580000"/>
-            <a:ext cx="10200000" cy="450000"/>
-          </a:xfrm>
-          <a:prstGeom prst="rect">
-            <a:avLst/>
-          </a:prstGeom>
-          <a:noFill/>
-        </p:spPr>
-        <p:txBody>
-          <a:bodyPr wrap="square" lIns="0" rIns="0" tIns="0" bIns="0">
-            <a:spAutoFit/>
-          </a:bodyPr>
-          <a:lstStyle/>
-          <a:p>
-            <a:pPr algn="l">
-              <a:defRPr sz="1700" b="0">
-                <a:solidFill>
-                  <a:srgbClr val="5A6376"/>
-                </a:solidFill>
-                <a:latin typeface="Aptos"/>
-              </a:defRPr>
-            </a:pPr>
-            <a:r>
-              <a:t>What the current project already offers, and what must be controlled before it can support a strong claim.</a:t>
-            </a:r>
-          </a:p>
-        </p:txBody>
-      </p:sp>
-      <p:sp>
-        <p:nvSpPr>
-          <p:cNvPr id="6" name="Rounded Rectangle 5"/>
+          <p:cNvPr id="5" name="Rounded Rectangle 4"/>
           <p:cNvSpPr/>
           <p:nvPr/>
         </p:nvSpPr>
         <p:spPr>
           <a:xfrm>
-            <a:off x="1082040" y="2270000"/>
-            <a:ext cx="4900000" cy="3100000"/>
+            <a:off x="1082040" y="1990000"/>
+            <a:ext cx="10296144" cy="3350000"/>
           </a:xfrm>
           <a:prstGeom prst="roundRect">
             <a:avLst/>
@@ -4193,14 +4157,14 @@
       </p:sp>
       <p:sp>
         <p:nvSpPr>
-          <p:cNvPr id="7" name="Rectangle 6"/>
+          <p:cNvPr id="6" name="Rectangle 5"/>
           <p:cNvSpPr/>
           <p:nvPr/>
         </p:nvSpPr>
         <p:spPr>
           <a:xfrm>
-            <a:off x="1082040" y="2270000"/>
-            <a:ext cx="4900000" cy="85000"/>
+            <a:off x="1082040" y="1990000"/>
+            <a:ext cx="10296144" cy="85000"/>
           </a:xfrm>
           <a:prstGeom prst="rect">
             <a:avLst/>
@@ -4236,14 +4200,14 @@
       </p:sp>
       <p:sp>
         <p:nvSpPr>
-          <p:cNvPr id="8" name="TextBox 7"/>
+          <p:cNvPr id="7" name="TextBox 6"/>
           <p:cNvSpPr txBox="1"/>
           <p:nvPr/>
         </p:nvSpPr>
         <p:spPr>
           <a:xfrm>
-            <a:off x="1292040" y="2430000"/>
-            <a:ext cx="4480000" cy="310000"/>
+            <a:off x="1292040" y="2150000"/>
+            <a:ext cx="9876144" cy="310000"/>
           </a:xfrm>
           <a:prstGeom prst="rect">
             <a:avLst/>
@@ -4265,21 +4229,21 @@
               </a:defRPr>
             </a:pPr>
             <a:r>
-              <a:t>Useful ingredients already in place</a:t>
-            </a:r>
-          </a:p>
-        </p:txBody>
-      </p:sp>
-      <p:sp>
-        <p:nvSpPr>
-          <p:cNvPr id="9" name="TextBox 8"/>
+              <a:t>What we already have</a:t>
+            </a:r>
+          </a:p>
+        </p:txBody>
+      </p:sp>
+      <p:sp>
+        <p:nvSpPr>
+          <p:cNvPr id="8" name="TextBox 7"/>
           <p:cNvSpPr txBox="1"/>
           <p:nvPr/>
         </p:nvSpPr>
         <p:spPr>
           <a:xfrm>
-            <a:off x="1292040" y="2860000"/>
-            <a:ext cx="4480000" cy="2340000"/>
+            <a:off x="1292040" y="2580000"/>
+            <a:ext cx="9876144" cy="2590000"/>
           </a:xfrm>
           <a:prstGeom prst="rect">
             <a:avLst/>
@@ -4304,194 +4268,19 @@
               </a:defRPr>
             </a:pPr>
             <a:r>
-              <a:t>• Staged adaptation from a LibriSpeech CTC checkpoint to held-out-accent L2-ARCTIC.</a:t>
+              <a:t>• Staged LibriSpeech-to-L2-ARCTIC adaptation.</a:t>
             </a:r>
             <a:br/>
             <a:r>
-              <a:t>• Content-parallel utterance pairs across speakers, with external ASR benchmarks.</a:t>
+              <a:t>• Content-parallel utterance pairs across speakers.</a:t>
             </a:r>
             <a:br/>
             <a:r>
-              <a:t>• Layer-wise content geometry and cross-accent L1 diagnostics.</a:t>
+              <a:t>• Leave-one-accent-out evaluation.</a:t>
             </a:r>
             <a:br/>
             <a:r>
-              <a:t>• A concrete downstream setting for asking whether representations predict task performance.</a:t>
-            </a:r>
-          </a:p>
-        </p:txBody>
-      </p:sp>
-      <p:sp>
-        <p:nvSpPr>
-          <p:cNvPr id="10" name="Rounded Rectangle 9"/>
-          <p:cNvSpPr/>
-          <p:nvPr/>
-        </p:nvSpPr>
-        <p:spPr>
-          <a:xfrm>
-            <a:off x="6220000" y="2270000"/>
-            <a:ext cx="4900000" cy="3100000"/>
-          </a:xfrm>
-          <a:prstGeom prst="roundRect">
-            <a:avLst/>
-          </a:prstGeom>
-          <a:solidFill>
-            <a:srgbClr val="F7F8FC"/>
-          </a:solidFill>
-          <a:ln w="10160">
-            <a:solidFill>
-              <a:srgbClr val="EEF1F8"/>
-            </a:solidFill>
-          </a:ln>
-        </p:spPr>
-        <p:style>
-          <a:lnRef idx="1">
-            <a:schemeClr val="accent1"/>
-          </a:lnRef>
-          <a:fillRef idx="3">
-            <a:schemeClr val="accent1"/>
-          </a:fillRef>
-          <a:effectRef idx="2">
-            <a:schemeClr val="accent1"/>
-          </a:effectRef>
-          <a:fontRef idx="minor">
-            <a:schemeClr val="lt1"/>
-          </a:fontRef>
-        </p:style>
-        <p:txBody>
-          <a:bodyPr rtlCol="0" anchor="ctr"/>
-          <a:lstStyle/>
-          <a:p>
-            <a:pPr algn="ctr"/>
-          </a:p>
-        </p:txBody>
-      </p:sp>
-      <p:sp>
-        <p:nvSpPr>
-          <p:cNvPr id="11" name="Rectangle 10"/>
-          <p:cNvSpPr/>
-          <p:nvPr/>
-        </p:nvSpPr>
-        <p:spPr>
-          <a:xfrm>
-            <a:off x="6220000" y="2270000"/>
-            <a:ext cx="4900000" cy="85000"/>
-          </a:xfrm>
-          <a:prstGeom prst="rect">
-            <a:avLst/>
-          </a:prstGeom>
-          <a:solidFill>
-            <a:srgbClr val="5A6376"/>
-          </a:solidFill>
-          <a:ln>
-            <a:noFill/>
-          </a:ln>
-        </p:spPr>
-        <p:style>
-          <a:lnRef idx="1">
-            <a:schemeClr val="accent1"/>
-          </a:lnRef>
-          <a:fillRef idx="3">
-            <a:schemeClr val="accent1"/>
-          </a:fillRef>
-          <a:effectRef idx="2">
-            <a:schemeClr val="accent1"/>
-          </a:effectRef>
-          <a:fontRef idx="minor">
-            <a:schemeClr val="lt1"/>
-          </a:fontRef>
-        </p:style>
-        <p:txBody>
-          <a:bodyPr rtlCol="0" anchor="ctr"/>
-          <a:lstStyle/>
-          <a:p>
-            <a:pPr algn="ctr"/>
-          </a:p>
-        </p:txBody>
-      </p:sp>
-      <p:sp>
-        <p:nvSpPr>
-          <p:cNvPr id="12" name="TextBox 11"/>
-          <p:cNvSpPr txBox="1"/>
-          <p:nvPr/>
-        </p:nvSpPr>
-        <p:spPr>
-          <a:xfrm>
-            <a:off x="6430000" y="2430000"/>
-            <a:ext cx="4480000" cy="310000"/>
-          </a:xfrm>
-          <a:prstGeom prst="rect">
-            <a:avLst/>
-          </a:prstGeom>
-          <a:noFill/>
-        </p:spPr>
-        <p:txBody>
-          <a:bodyPr wrap="square" lIns="0" rIns="0" tIns="0" bIns="0">
-            <a:spAutoFit/>
-          </a:bodyPr>
-          <a:lstStyle/>
-          <a:p>
-            <a:pPr algn="l">
-              <a:defRPr sz="1800" b="1">
-                <a:solidFill>
-                  <a:srgbClr val="1F2636"/>
-                </a:solidFill>
-                <a:latin typeface="Aptos"/>
-              </a:defRPr>
-            </a:pPr>
-            <a:r>
-              <a:t>Gaps to close before using the result</a:t>
-            </a:r>
-          </a:p>
-        </p:txBody>
-      </p:sp>
-      <p:sp>
-        <p:nvSpPr>
-          <p:cNvPr id="13" name="TextBox 12"/>
-          <p:cNvSpPr txBox="1"/>
-          <p:nvPr/>
-        </p:nvSpPr>
-        <p:spPr>
-          <a:xfrm>
-            <a:off x="6430000" y="2860000"/>
-            <a:ext cx="4480000" cy="2340000"/>
-          </a:xfrm>
-          <a:prstGeom prst="rect">
-            <a:avLst/>
-          </a:prstGeom>
-          <a:noFill/>
-        </p:spPr>
-        <p:txBody>
-          <a:bodyPr wrap="square" lIns="0" rIns="0" tIns="0" bIns="0">
-            <a:spAutoFit/>
-          </a:bodyPr>
-          <a:lstStyle/>
-          <a:p>
-            <a:pPr algn="l">
-              <a:spcAft>
-                <a:spcPts val="600"/>
-              </a:spcAft>
-              <a:defRPr sz="1500" b="0">
-                <a:solidFill>
-                  <a:srgbClr val="1F2636"/>
-                </a:solidFill>
-                <a:latin typeface="Aptos"/>
-              </a:defRPr>
-            </a:pPr>
-            <a:r>
-              <a:t>• Identical seed coverage for every baseline and every held-out accent.</a:t>
-            </a:r>
-            <a:br/>
-            <a:r>
-              <a:t>• Geometry extracted from the exact checkpoints used for the ASR comparison.</a:t>
-            </a:r>
-            <a:br/>
-            <a:r>
-              <a:t>• A shuffled-content positive control to separate content supervision from generic regularization.</a:t>
-            </a:r>
-            <a:br/>
-            <a:r>
-              <a:t>• Paired uncertainty: per-seed, per-fold, and utterance-level comparisons.</a:t>
+              <a:t>• ASR and representation diagnostics.</a:t>
             </a:r>
           </a:p>
         </p:txBody>
@@ -4545,7 +4334,7 @@
               </a:defRPr>
             </a:pPr>
             <a:r>
-              <a:t>Minimal controlled accented-ASR experiment</a:t>
+              <a:t>Accented ASR: missing experiments</a:t>
             </a:r>
           </a:p>
         </p:txBody>
@@ -4631,60 +4420,24 @@
       </p:sp>
       <p:sp>
         <p:nvSpPr>
-          <p:cNvPr id="5" name="TextBox 4"/>
-          <p:cNvSpPr txBox="1"/>
-          <p:nvPr/>
-        </p:nvSpPr>
-        <p:spPr>
-          <a:xfrm>
-            <a:off x="1082040" y="1580000"/>
-            <a:ext cx="10200000" cy="430000"/>
-          </a:xfrm>
-          <a:prstGeom prst="rect">
-            <a:avLst/>
-          </a:prstGeom>
-          <a:noFill/>
-        </p:spPr>
-        <p:txBody>
-          <a:bodyPr wrap="square" lIns="0" rIns="0" tIns="0" bIns="0">
-            <a:spAutoFit/>
-          </a:bodyPr>
-          <a:lstStyle/>
-          <a:p>
-            <a:pPr algn="l">
-              <a:defRPr sz="1800" b="0">
-                <a:solidFill>
-                  <a:srgbClr val="5A6376"/>
-                </a:solidFill>
-                <a:latin typeface="Aptos"/>
-              </a:defRPr>
-            </a:pPr>
-            <a:r>
-              <a:t>Hold all optimisation choices fixed; change only how contrastive positives are defined.</a:t>
-            </a:r>
-          </a:p>
-        </p:txBody>
-      </p:sp>
-      <p:sp>
-        <p:nvSpPr>
-          <p:cNvPr id="6" name="Rounded Rectangle 5"/>
+          <p:cNvPr id="5" name="Rounded Rectangle 4"/>
           <p:cNvSpPr/>
           <p:nvPr/>
         </p:nvSpPr>
         <p:spPr>
           <a:xfrm>
-            <a:off x="720000" y="2620000"/>
-            <a:ext cx="2100000" cy="1120000"/>
+            <a:off x="1082040" y="1990000"/>
+            <a:ext cx="10296144" cy="3350000"/>
           </a:xfrm>
           <a:prstGeom prst="roundRect">
             <a:avLst/>
           </a:prstGeom>
           <a:solidFill>
-            <a:srgbClr val="FFFFFF"/>
+            <a:srgbClr val="F7F8FC"/>
           </a:solidFill>
-          <a:ln w="13970">
+          <a:ln w="10160">
             <a:solidFill>
-              <a:srgbClr val="5A6376"/>
+              <a:srgbClr val="EEF1F8"/>
             </a:solidFill>
           </a:ln>
         </p:spPr>
@@ -4712,100 +4465,20 @@
       </p:sp>
       <p:sp>
         <p:nvSpPr>
-          <p:cNvPr id="7" name="TextBox 6"/>
-          <p:cNvSpPr txBox="1"/>
-          <p:nvPr/>
-        </p:nvSpPr>
-        <p:spPr>
-          <a:xfrm>
-            <a:off x="840000" y="2750000"/>
-            <a:ext cx="1860000" cy="250000"/>
+          <p:cNvPr id="6" name="Rectangle 5"/>
+          <p:cNvSpPr/>
+          <p:nvPr/>
+        </p:nvSpPr>
+        <p:spPr>
+          <a:xfrm>
+            <a:off x="1082040" y="1990000"/>
+            <a:ext cx="10296144" cy="85000"/>
           </a:xfrm>
           <a:prstGeom prst="rect">
             <a:avLst/>
           </a:prstGeom>
-          <a:noFill/>
-        </p:spPr>
-        <p:txBody>
-          <a:bodyPr wrap="square" lIns="0" rIns="0" tIns="0" bIns="0">
-            <a:spAutoFit/>
-          </a:bodyPr>
-          <a:lstStyle/>
-          <a:p>
-            <a:pPr algn="ctr">
-              <a:defRPr sz="1500" b="1">
-                <a:solidFill>
-                  <a:srgbClr val="1F2636"/>
-                </a:solidFill>
-                <a:latin typeface="Aptos"/>
-              </a:defRPr>
-            </a:pPr>
-            <a:r>
-              <a:t>Shared starting point</a:t>
-            </a:r>
-          </a:p>
-        </p:txBody>
-      </p:sp>
-      <p:sp>
-        <p:nvSpPr>
-          <p:cNvPr id="8" name="TextBox 7"/>
-          <p:cNvSpPr txBox="1"/>
-          <p:nvPr/>
-        </p:nvSpPr>
-        <p:spPr>
-          <a:xfrm>
-            <a:off x="840000" y="3090000"/>
-            <a:ext cx="1860000" cy="530000"/>
-          </a:xfrm>
-          <a:prstGeom prst="rect">
-            <a:avLst/>
-          </a:prstGeom>
-          <a:noFill/>
-        </p:spPr>
-        <p:txBody>
-          <a:bodyPr wrap="square" lIns="0" rIns="0" tIns="0" bIns="0">
-            <a:spAutoFit/>
-          </a:bodyPr>
-          <a:lstStyle/>
-          <a:p>
-            <a:pPr algn="ctr">
-              <a:defRPr sz="1200" b="0">
-                <a:solidFill>
-                  <a:srgbClr val="5A6376"/>
-                </a:solidFill>
-                <a:latin typeface="Aptos"/>
-              </a:defRPr>
-            </a:pPr>
-            <a:r>
-              <a:t>Same LibriSpeech CTC checkpoint</a:t>
-            </a:r>
-            <a:br/>
-            <a:r>
-              <a:t>Same held-out-accent fold</a:t>
-            </a:r>
-            <a:br/>
-            <a:r>
-              <a:t>Same seeds</a:t>
-            </a:r>
-          </a:p>
-        </p:txBody>
-      </p:sp>
-      <p:sp>
-        <p:nvSpPr>
-          <p:cNvPr id="9" name="Right Arrow 8"/>
-          <p:cNvSpPr/>
-          <p:nvPr/>
-        </p:nvSpPr>
-        <p:spPr>
-          <a:xfrm>
-            <a:off x="2910000" y="3085000"/>
-            <a:ext cx="380000" cy="180000"/>
-          </a:xfrm>
-          <a:prstGeom prst="rightArrow">
-            <a:avLst/>
-          </a:prstGeom>
           <a:solidFill>
-            <a:srgbClr val="5A6376"/>
+            <a:srgbClr val="405294"/>
           </a:solidFill>
           <a:ln>
             <a:noFill/>
@@ -4835,59 +4508,14 @@
       </p:sp>
       <p:sp>
         <p:nvSpPr>
-          <p:cNvPr id="10" name="Rounded Rectangle 9"/>
-          <p:cNvSpPr/>
-          <p:nvPr/>
-        </p:nvSpPr>
-        <p:spPr>
-          <a:xfrm>
-            <a:off x="3340000" y="2620000"/>
-            <a:ext cx="2100000" cy="1120000"/>
-          </a:xfrm>
-          <a:prstGeom prst="roundRect">
-            <a:avLst/>
-          </a:prstGeom>
-          <a:solidFill>
-            <a:srgbClr val="FFFFFF"/>
-          </a:solidFill>
-          <a:ln w="13970">
-            <a:solidFill>
-              <a:srgbClr val="5A6376"/>
-            </a:solidFill>
-          </a:ln>
-        </p:spPr>
-        <p:style>
-          <a:lnRef idx="1">
-            <a:schemeClr val="accent1"/>
-          </a:lnRef>
-          <a:fillRef idx="3">
-            <a:schemeClr val="accent1"/>
-          </a:fillRef>
-          <a:effectRef idx="2">
-            <a:schemeClr val="accent1"/>
-          </a:effectRef>
-          <a:fontRef idx="minor">
-            <a:schemeClr val="lt1"/>
-          </a:fontRef>
-        </p:style>
-        <p:txBody>
-          <a:bodyPr rtlCol="0" anchor="ctr"/>
-          <a:lstStyle/>
-          <a:p>
-            <a:pPr algn="ctr"/>
-          </a:p>
-        </p:txBody>
-      </p:sp>
-      <p:sp>
-        <p:nvSpPr>
-          <p:cNvPr id="11" name="TextBox 10"/>
+          <p:cNvPr id="7" name="TextBox 6"/>
           <p:cNvSpPr txBox="1"/>
           <p:nvPr/>
         </p:nvSpPr>
         <p:spPr>
           <a:xfrm>
-            <a:off x="3460000" y="2750000"/>
-            <a:ext cx="1860000" cy="250000"/>
+            <a:off x="1292040" y="2150000"/>
+            <a:ext cx="9876144" cy="310000"/>
           </a:xfrm>
           <a:prstGeom prst="rect">
             <a:avLst/>
@@ -4900,8 +4528,8 @@
           </a:bodyPr>
           <a:lstStyle/>
           <a:p>
-            <a:pPr algn="ctr">
-              <a:defRPr sz="1500" b="1">
+            <a:pPr algn="l">
+              <a:defRPr sz="1800" b="1">
                 <a:solidFill>
                   <a:srgbClr val="1F2636"/>
                 </a:solidFill>
@@ -4909,549 +4537,21 @@
               </a:defRPr>
             </a:pPr>
             <a:r>
-              <a:t>Staged MD-FT</a:t>
-            </a:r>
-          </a:p>
-        </p:txBody>
-      </p:sp>
-      <p:sp>
-        <p:nvSpPr>
-          <p:cNvPr id="12" name="TextBox 11"/>
+              <a:t>Priority order</a:t>
+            </a:r>
+          </a:p>
+        </p:txBody>
+      </p:sp>
+      <p:sp>
+        <p:nvSpPr>
+          <p:cNvPr id="8" name="TextBox 7"/>
           <p:cNvSpPr txBox="1"/>
           <p:nvPr/>
         </p:nvSpPr>
         <p:spPr>
           <a:xfrm>
-            <a:off x="3460000" y="3090000"/>
-            <a:ext cx="1860000" cy="530000"/>
-          </a:xfrm>
-          <a:prstGeom prst="rect">
-            <a:avLst/>
-          </a:prstGeom>
-          <a:noFill/>
-        </p:spPr>
-        <p:txBody>
-          <a:bodyPr wrap="square" lIns="0" rIns="0" tIns="0" bIns="0">
-            <a:spAutoFit/>
-          </a:bodyPr>
-          <a:lstStyle/>
-          <a:p>
-            <a:pPr algn="ctr">
-              <a:defRPr sz="1200" b="0">
-                <a:solidFill>
-                  <a:srgbClr val="5A6376"/>
-                </a:solidFill>
-                <a:latin typeface="Aptos"/>
-              </a:defRPr>
-            </a:pPr>
-            <a:r>
-              <a:t>L2-ARCTIC CTC adaptation</a:t>
-            </a:r>
-            <a:br/>
-            <a:r>
-              <a:t>No contrastive term</a:t>
-            </a:r>
-          </a:p>
-        </p:txBody>
-      </p:sp>
-      <p:sp>
-        <p:nvSpPr>
-          <p:cNvPr id="13" name="Right Arrow 12"/>
-          <p:cNvSpPr/>
-          <p:nvPr/>
-        </p:nvSpPr>
-        <p:spPr>
-          <a:xfrm>
-            <a:off x="5530000" y="3085000"/>
-            <a:ext cx="380000" cy="180000"/>
-          </a:xfrm>
-          <a:prstGeom prst="rightArrow">
-            <a:avLst/>
-          </a:prstGeom>
-          <a:solidFill>
-            <a:srgbClr val="5A6376"/>
-          </a:solidFill>
-          <a:ln>
-            <a:noFill/>
-          </a:ln>
-        </p:spPr>
-        <p:style>
-          <a:lnRef idx="1">
-            <a:schemeClr val="accent1"/>
-          </a:lnRef>
-          <a:fillRef idx="3">
-            <a:schemeClr val="accent1"/>
-          </a:fillRef>
-          <a:effectRef idx="2">
-            <a:schemeClr val="accent1"/>
-          </a:effectRef>
-          <a:fontRef idx="minor">
-            <a:schemeClr val="lt1"/>
-          </a:fontRef>
-        </p:style>
-        <p:txBody>
-          <a:bodyPr rtlCol="0" anchor="ctr"/>
-          <a:lstStyle/>
-          <a:p>
-            <a:pPr algn="ctr"/>
-          </a:p>
-        </p:txBody>
-      </p:sp>
-      <p:sp>
-        <p:nvSpPr>
-          <p:cNvPr id="14" name="Rounded Rectangle 13"/>
-          <p:cNvSpPr/>
-          <p:nvPr/>
-        </p:nvSpPr>
-        <p:spPr>
-          <a:xfrm>
-            <a:off x="5960000" y="2620000"/>
-            <a:ext cx="2100000" cy="1120000"/>
-          </a:xfrm>
-          <a:prstGeom prst="roundRect">
-            <a:avLst/>
-          </a:prstGeom>
-          <a:solidFill>
-            <a:srgbClr val="EEF1F8"/>
-          </a:solidFill>
-          <a:ln w="13970">
-            <a:solidFill>
-              <a:srgbClr val="405294"/>
-            </a:solidFill>
-          </a:ln>
-        </p:spPr>
-        <p:style>
-          <a:lnRef idx="1">
-            <a:schemeClr val="accent1"/>
-          </a:lnRef>
-          <a:fillRef idx="3">
-            <a:schemeClr val="accent1"/>
-          </a:fillRef>
-          <a:effectRef idx="2">
-            <a:schemeClr val="accent1"/>
-          </a:effectRef>
-          <a:fontRef idx="minor">
-            <a:schemeClr val="lt1"/>
-          </a:fontRef>
-        </p:style>
-        <p:txBody>
-          <a:bodyPr rtlCol="0" anchor="ctr"/>
-          <a:lstStyle/>
-          <a:p>
-            <a:pPr algn="ctr"/>
-          </a:p>
-        </p:txBody>
-      </p:sp>
-      <p:sp>
-        <p:nvSpPr>
-          <p:cNvPr id="15" name="TextBox 14"/>
-          <p:cNvSpPr txBox="1"/>
-          <p:nvPr/>
-        </p:nvSpPr>
-        <p:spPr>
-          <a:xfrm>
-            <a:off x="6080000" y="2750000"/>
-            <a:ext cx="1860000" cy="250000"/>
-          </a:xfrm>
-          <a:prstGeom prst="rect">
-            <a:avLst/>
-          </a:prstGeom>
-          <a:noFill/>
-        </p:spPr>
-        <p:txBody>
-          <a:bodyPr wrap="square" lIns="0" rIns="0" tIns="0" bIns="0">
-            <a:spAutoFit/>
-          </a:bodyPr>
-          <a:lstStyle/>
-          <a:p>
-            <a:pPr algn="ctr">
-              <a:defRPr sz="1500" b="1">
-                <a:solidFill>
-                  <a:srgbClr val="405294"/>
-                </a:solidFill>
-                <a:latin typeface="Aptos"/>
-              </a:defRPr>
-            </a:pPr>
-            <a:r>
-              <a:t>True CP-SupCon</a:t>
-            </a:r>
-          </a:p>
-        </p:txBody>
-      </p:sp>
-      <p:sp>
-        <p:nvSpPr>
-          <p:cNvPr id="16" name="TextBox 15"/>
-          <p:cNvSpPr txBox="1"/>
-          <p:nvPr/>
-        </p:nvSpPr>
-        <p:spPr>
-          <a:xfrm>
-            <a:off x="6080000" y="3090000"/>
-            <a:ext cx="1860000" cy="530000"/>
-          </a:xfrm>
-          <a:prstGeom prst="rect">
-            <a:avLst/>
-          </a:prstGeom>
-          <a:noFill/>
-        </p:spPr>
-        <p:txBody>
-          <a:bodyPr wrap="square" lIns="0" rIns="0" tIns="0" bIns="0">
-            <a:spAutoFit/>
-          </a:bodyPr>
-          <a:lstStyle/>
-          <a:p>
-            <a:pPr algn="ctr">
-              <a:defRPr sz="1200" b="0">
-                <a:solidFill>
-                  <a:srgbClr val="5A6376"/>
-                </a:solidFill>
-                <a:latin typeface="Aptos"/>
-              </a:defRPr>
-            </a:pPr>
-            <a:r>
-              <a:t>Positive pairs: same prompt</a:t>
-            </a:r>
-            <a:br/>
-            <a:r>
-              <a:t>Different speakers</a:t>
-            </a:r>
-          </a:p>
-        </p:txBody>
-      </p:sp>
-      <p:sp>
-        <p:nvSpPr>
-          <p:cNvPr id="17" name="Right Arrow 16"/>
-          <p:cNvSpPr/>
-          <p:nvPr/>
-        </p:nvSpPr>
-        <p:spPr>
-          <a:xfrm>
-            <a:off x="8150000" y="3085000"/>
-            <a:ext cx="380000" cy="180000"/>
-          </a:xfrm>
-          <a:prstGeom prst="rightArrow">
-            <a:avLst/>
-          </a:prstGeom>
-          <a:solidFill>
-            <a:srgbClr val="5A6376"/>
-          </a:solidFill>
-          <a:ln>
-            <a:noFill/>
-          </a:ln>
-        </p:spPr>
-        <p:style>
-          <a:lnRef idx="1">
-            <a:schemeClr val="accent1"/>
-          </a:lnRef>
-          <a:fillRef idx="3">
-            <a:schemeClr val="accent1"/>
-          </a:fillRef>
-          <a:effectRef idx="2">
-            <a:schemeClr val="accent1"/>
-          </a:effectRef>
-          <a:fontRef idx="minor">
-            <a:schemeClr val="lt1"/>
-          </a:fontRef>
-        </p:style>
-        <p:txBody>
-          <a:bodyPr rtlCol="0" anchor="ctr"/>
-          <a:lstStyle/>
-          <a:p>
-            <a:pPr algn="ctr"/>
-          </a:p>
-        </p:txBody>
-      </p:sp>
-      <p:sp>
-        <p:nvSpPr>
-          <p:cNvPr id="18" name="Rounded Rectangle 17"/>
-          <p:cNvSpPr/>
-          <p:nvPr/>
-        </p:nvSpPr>
-        <p:spPr>
-          <a:xfrm>
-            <a:off x="8580000" y="2620000"/>
-            <a:ext cx="2100000" cy="1120000"/>
-          </a:xfrm>
-          <a:prstGeom prst="roundRect">
-            <a:avLst/>
-          </a:prstGeom>
-          <a:solidFill>
-            <a:srgbClr val="FFFFFF"/>
-          </a:solidFill>
-          <a:ln w="13970">
-            <a:solidFill>
-              <a:srgbClr val="5A6376"/>
-            </a:solidFill>
-          </a:ln>
-        </p:spPr>
-        <p:style>
-          <a:lnRef idx="1">
-            <a:schemeClr val="accent1"/>
-          </a:lnRef>
-          <a:fillRef idx="3">
-            <a:schemeClr val="accent1"/>
-          </a:fillRef>
-          <a:effectRef idx="2">
-            <a:schemeClr val="accent1"/>
-          </a:effectRef>
-          <a:fontRef idx="minor">
-            <a:schemeClr val="lt1"/>
-          </a:fontRef>
-        </p:style>
-        <p:txBody>
-          <a:bodyPr rtlCol="0" anchor="ctr"/>
-          <a:lstStyle/>
-          <a:p>
-            <a:pPr algn="ctr"/>
-          </a:p>
-        </p:txBody>
-      </p:sp>
-      <p:sp>
-        <p:nvSpPr>
-          <p:cNvPr id="19" name="TextBox 18"/>
-          <p:cNvSpPr txBox="1"/>
-          <p:nvPr/>
-        </p:nvSpPr>
-        <p:spPr>
-          <a:xfrm>
-            <a:off x="8700000" y="2750000"/>
-            <a:ext cx="1860000" cy="250000"/>
-          </a:xfrm>
-          <a:prstGeom prst="rect">
-            <a:avLst/>
-          </a:prstGeom>
-          <a:noFill/>
-        </p:spPr>
-        <p:txBody>
-          <a:bodyPr wrap="square" lIns="0" rIns="0" tIns="0" bIns="0">
-            <a:spAutoFit/>
-          </a:bodyPr>
-          <a:lstStyle/>
-          <a:p>
-            <a:pPr algn="ctr">
-              <a:defRPr sz="1500" b="1">
-                <a:solidFill>
-                  <a:srgbClr val="1F2636"/>
-                </a:solidFill>
-                <a:latin typeface="Aptos"/>
-              </a:defRPr>
-            </a:pPr>
-            <a:r>
-              <a:t>Shuffled control</a:t>
-            </a:r>
-          </a:p>
-        </p:txBody>
-      </p:sp>
-      <p:sp>
-        <p:nvSpPr>
-          <p:cNvPr id="20" name="TextBox 19"/>
-          <p:cNvSpPr txBox="1"/>
-          <p:nvPr/>
-        </p:nvSpPr>
-        <p:spPr>
-          <a:xfrm>
-            <a:off x="8700000" y="3090000"/>
-            <a:ext cx="1860000" cy="530000"/>
-          </a:xfrm>
-          <a:prstGeom prst="rect">
-            <a:avLst/>
-          </a:prstGeom>
-          <a:noFill/>
-        </p:spPr>
-        <p:txBody>
-          <a:bodyPr wrap="square" lIns="0" rIns="0" tIns="0" bIns="0">
-            <a:spAutoFit/>
-          </a:bodyPr>
-          <a:lstStyle/>
-          <a:p>
-            <a:pPr algn="ctr">
-              <a:defRPr sz="1200" b="0">
-                <a:solidFill>
-                  <a:srgbClr val="5A6376"/>
-                </a:solidFill>
-                <a:latin typeface="Aptos"/>
-              </a:defRPr>
-            </a:pPr>
-            <a:r>
-              <a:t>Positive pairs: random prompts</a:t>
-            </a:r>
-            <a:br/>
-            <a:r>
-              <a:t>Same loss and schedule</a:t>
-            </a:r>
-          </a:p>
-        </p:txBody>
-      </p:sp>
-      <p:sp>
-        <p:nvSpPr>
-          <p:cNvPr id="21" name="TextBox 20"/>
-          <p:cNvSpPr txBox="1"/>
-          <p:nvPr/>
-        </p:nvSpPr>
-        <p:spPr>
-          <a:xfrm>
-            <a:off x="1160000" y="4410000"/>
-            <a:ext cx="9800000" cy="400000"/>
-          </a:xfrm>
-          <a:prstGeom prst="rect">
-            <a:avLst/>
-          </a:prstGeom>
-          <a:noFill/>
-        </p:spPr>
-        <p:txBody>
-          <a:bodyPr wrap="square" lIns="0" rIns="0" tIns="0" bIns="0">
-            <a:spAutoFit/>
-          </a:bodyPr>
-          <a:lstStyle/>
-          <a:p>
-            <a:pPr algn="ctr">
-              <a:defRPr sz="1900" b="1">
-                <a:solidFill>
-                  <a:srgbClr val="405294"/>
-                </a:solidFill>
-                <a:latin typeface="Aptos"/>
-              </a:defRPr>
-            </a:pPr>
-            <a:r>
-              <a:t>Compare each branch with the same outputs</a:t>
-            </a:r>
-          </a:p>
-        </p:txBody>
-      </p:sp>
-      <p:sp>
-        <p:nvSpPr>
-          <p:cNvPr id="22" name="Rounded Rectangle 21"/>
-          <p:cNvSpPr/>
-          <p:nvPr/>
-        </p:nvSpPr>
-        <p:spPr>
-          <a:xfrm>
-            <a:off x="1900000" y="4930000"/>
-            <a:ext cx="3600000" cy="1020000"/>
-          </a:xfrm>
-          <a:prstGeom prst="roundRect">
-            <a:avLst/>
-          </a:prstGeom>
-          <a:solidFill>
-            <a:srgbClr val="F7F8FC"/>
-          </a:solidFill>
-          <a:ln w="10160">
-            <a:solidFill>
-              <a:srgbClr val="EEF1F8"/>
-            </a:solidFill>
-          </a:ln>
-        </p:spPr>
-        <p:style>
-          <a:lnRef idx="1">
-            <a:schemeClr val="accent1"/>
-          </a:lnRef>
-          <a:fillRef idx="3">
-            <a:schemeClr val="accent1"/>
-          </a:fillRef>
-          <a:effectRef idx="2">
-            <a:schemeClr val="accent1"/>
-          </a:effectRef>
-          <a:fontRef idx="minor">
-            <a:schemeClr val="lt1"/>
-          </a:fontRef>
-        </p:style>
-        <p:txBody>
-          <a:bodyPr rtlCol="0" anchor="ctr"/>
-          <a:lstStyle/>
-          <a:p>
-            <a:pPr algn="ctr"/>
-          </a:p>
-        </p:txBody>
-      </p:sp>
-      <p:sp>
-        <p:nvSpPr>
-          <p:cNvPr id="23" name="Rectangle 22"/>
-          <p:cNvSpPr/>
-          <p:nvPr/>
-        </p:nvSpPr>
-        <p:spPr>
-          <a:xfrm>
-            <a:off x="1900000" y="4930000"/>
-            <a:ext cx="3600000" cy="85000"/>
-          </a:xfrm>
-          <a:prstGeom prst="rect">
-            <a:avLst/>
-          </a:prstGeom>
-          <a:solidFill>
-            <a:srgbClr val="405294"/>
-          </a:solidFill>
-          <a:ln>
-            <a:noFill/>
-          </a:ln>
-        </p:spPr>
-        <p:style>
-          <a:lnRef idx="1">
-            <a:schemeClr val="accent1"/>
-          </a:lnRef>
-          <a:fillRef idx="3">
-            <a:schemeClr val="accent1"/>
-          </a:fillRef>
-          <a:effectRef idx="2">
-            <a:schemeClr val="accent1"/>
-          </a:effectRef>
-          <a:fontRef idx="minor">
-            <a:schemeClr val="lt1"/>
-          </a:fontRef>
-        </p:style>
-        <p:txBody>
-          <a:bodyPr rtlCol="0" anchor="ctr"/>
-          <a:lstStyle/>
-          <a:p>
-            <a:pPr algn="ctr"/>
-          </a:p>
-        </p:txBody>
-      </p:sp>
-      <p:sp>
-        <p:nvSpPr>
-          <p:cNvPr id="24" name="TextBox 23"/>
-          <p:cNvSpPr txBox="1"/>
-          <p:nvPr/>
-        </p:nvSpPr>
-        <p:spPr>
-          <a:xfrm>
-            <a:off x="2110000" y="5090000"/>
-            <a:ext cx="3180000" cy="310000"/>
-          </a:xfrm>
-          <a:prstGeom prst="rect">
-            <a:avLst/>
-          </a:prstGeom>
-          <a:noFill/>
-        </p:spPr>
-        <p:txBody>
-          <a:bodyPr wrap="square" lIns="0" rIns="0" tIns="0" bIns="0">
-            <a:spAutoFit/>
-          </a:bodyPr>
-          <a:lstStyle/>
-          <a:p>
-            <a:pPr algn="l">
-              <a:defRPr sz="1800" b="1">
-                <a:solidFill>
-                  <a:srgbClr val="1F2636"/>
-                </a:solidFill>
-                <a:latin typeface="Aptos"/>
-              </a:defRPr>
-            </a:pPr>
-            <a:r>
-              <a:t>ASR outcome</a:t>
-            </a:r>
-          </a:p>
-        </p:txBody>
-      </p:sp>
-      <p:sp>
-        <p:nvSpPr>
-          <p:cNvPr id="25" name="TextBox 24"/>
-          <p:cNvSpPr txBox="1"/>
-          <p:nvPr/>
-        </p:nvSpPr>
-        <p:spPr>
-          <a:xfrm>
-            <a:off x="2110000" y="5520000"/>
-            <a:ext cx="3180000" cy="260000"/>
+            <a:off x="1292040" y="2580000"/>
+            <a:ext cx="9876144" cy="2590000"/>
           </a:xfrm>
           <a:prstGeom prst="rect">
             <a:avLst/>
@@ -5476,178 +4576,19 @@
               </a:defRPr>
             </a:pPr>
             <a:r>
-              <a:t>• L2-ARCTIC, AESRC, SAA</a:t>
+              <a:t>• Complete seeds 42 and 77 for every baseline.</a:t>
             </a:r>
             <a:br/>
             <a:r>
-              <a:t>• greedy and fixed-LM decoding</a:t>
-            </a:r>
-          </a:p>
-        </p:txBody>
-      </p:sp>
-      <p:sp>
-        <p:nvSpPr>
-          <p:cNvPr id="26" name="Rounded Rectangle 25"/>
-          <p:cNvSpPr/>
-          <p:nvPr/>
-        </p:nvSpPr>
-        <p:spPr>
-          <a:xfrm>
-            <a:off x="6660000" y="4930000"/>
-            <a:ext cx="3600000" cy="1020000"/>
-          </a:xfrm>
-          <a:prstGeom prst="roundRect">
-            <a:avLst/>
-          </a:prstGeom>
-          <a:solidFill>
-            <a:srgbClr val="F7F8FC"/>
-          </a:solidFill>
-          <a:ln w="10160">
-            <a:solidFill>
-              <a:srgbClr val="EEF1F8"/>
-            </a:solidFill>
-          </a:ln>
-        </p:spPr>
-        <p:style>
-          <a:lnRef idx="1">
-            <a:schemeClr val="accent1"/>
-          </a:lnRef>
-          <a:fillRef idx="3">
-            <a:schemeClr val="accent1"/>
-          </a:fillRef>
-          <a:effectRef idx="2">
-            <a:schemeClr val="accent1"/>
-          </a:effectRef>
-          <a:fontRef idx="minor">
-            <a:schemeClr val="lt1"/>
-          </a:fontRef>
-        </p:style>
-        <p:txBody>
-          <a:bodyPr rtlCol="0" anchor="ctr"/>
-          <a:lstStyle/>
-          <a:p>
-            <a:pPr algn="ctr"/>
-          </a:p>
-        </p:txBody>
-      </p:sp>
-      <p:sp>
-        <p:nvSpPr>
-          <p:cNvPr id="27" name="Rectangle 26"/>
-          <p:cNvSpPr/>
-          <p:nvPr/>
-        </p:nvSpPr>
-        <p:spPr>
-          <a:xfrm>
-            <a:off x="6660000" y="4930000"/>
-            <a:ext cx="3600000" cy="85000"/>
-          </a:xfrm>
-          <a:prstGeom prst="rect">
-            <a:avLst/>
-          </a:prstGeom>
-          <a:solidFill>
-            <a:srgbClr val="405294"/>
-          </a:solidFill>
-          <a:ln>
-            <a:noFill/>
-          </a:ln>
-        </p:spPr>
-        <p:style>
-          <a:lnRef idx="1">
-            <a:schemeClr val="accent1"/>
-          </a:lnRef>
-          <a:fillRef idx="3">
-            <a:schemeClr val="accent1"/>
-          </a:fillRef>
-          <a:effectRef idx="2">
-            <a:schemeClr val="accent1"/>
-          </a:effectRef>
-          <a:fontRef idx="minor">
-            <a:schemeClr val="lt1"/>
-          </a:fontRef>
-        </p:style>
-        <p:txBody>
-          <a:bodyPr rtlCol="0" anchor="ctr"/>
-          <a:lstStyle/>
-          <a:p>
-            <a:pPr algn="ctr"/>
-          </a:p>
-        </p:txBody>
-      </p:sp>
-      <p:sp>
-        <p:nvSpPr>
-          <p:cNvPr id="28" name="TextBox 27"/>
-          <p:cNvSpPr txBox="1"/>
-          <p:nvPr/>
-        </p:nvSpPr>
-        <p:spPr>
-          <a:xfrm>
-            <a:off x="6870000" y="5090000"/>
-            <a:ext cx="3180000" cy="310000"/>
-          </a:xfrm>
-          <a:prstGeom prst="rect">
-            <a:avLst/>
-          </a:prstGeom>
-          <a:noFill/>
-        </p:spPr>
-        <p:txBody>
-          <a:bodyPr wrap="square" lIns="0" rIns="0" tIns="0" bIns="0">
-            <a:spAutoFit/>
-          </a:bodyPr>
-          <a:lstStyle/>
-          <a:p>
-            <a:pPr algn="l">
-              <a:defRPr sz="1800" b="1">
-                <a:solidFill>
-                  <a:srgbClr val="1F2636"/>
-                </a:solidFill>
-                <a:latin typeface="Aptos"/>
-              </a:defRPr>
-            </a:pPr>
-            <a:r>
-              <a:t>Representation outcome</a:t>
-            </a:r>
-          </a:p>
-        </p:txBody>
-      </p:sp>
-      <p:sp>
-        <p:nvSpPr>
-          <p:cNvPr id="29" name="TextBox 28"/>
-          <p:cNvSpPr txBox="1"/>
-          <p:nvPr/>
-        </p:nvSpPr>
-        <p:spPr>
-          <a:xfrm>
-            <a:off x="6870000" y="5520000"/>
-            <a:ext cx="3180000" cy="260000"/>
-          </a:xfrm>
-          <a:prstGeom prst="rect">
-            <a:avLst/>
-          </a:prstGeom>
-          <a:noFill/>
-        </p:spPr>
-        <p:txBody>
-          <a:bodyPr wrap="square" lIns="0" rIns="0" tIns="0" bIns="0">
-            <a:spAutoFit/>
-          </a:bodyPr>
-          <a:lstStyle/>
-          <a:p>
-            <a:pPr algn="l">
-              <a:spcAft>
-                <a:spcPts val="600"/>
-              </a:spcAft>
-              <a:defRPr sz="1500" b="0">
-                <a:solidFill>
-                  <a:srgbClr val="1F2636"/>
-                </a:solidFill>
-                <a:latin typeface="Aptos"/>
-              </a:defRPr>
-            </a:pPr>
-            <a:r>
-              <a:t>• same-prompt retrieval and alignment</a:t>
+              <a:t>• Train the shuffled-content CP-SupCon control.</a:t>
             </a:r>
             <a:br/>
             <a:r>
-              <a:t>• same checkpoints, layer by layer</a:t>
+              <a:t>• Extract geometry from the exact staged checkpoints.</a:t>
+            </a:r>
+            <a:br/>
+            <a:r>
+              <a:t>• Run matched ASR evaluation and paired statistics.</a:t>
             </a:r>
           </a:p>
         </p:txBody>
@@ -5701,7 +4642,7 @@
               </a:defRPr>
             </a:pPr>
             <a:r>
-              <a:t>Connection to the pretraining-dynamics project</a:t>
+              <a:t>How it links to pretraining dynamics</a:t>
             </a:r>
           </a:p>
         </p:txBody>
@@ -5787,50 +4728,14 @@
       </p:sp>
       <p:sp>
         <p:nvSpPr>
-          <p:cNvPr id="5" name="TextBox 4"/>
-          <p:cNvSpPr txBox="1"/>
-          <p:nvPr/>
-        </p:nvSpPr>
-        <p:spPr>
-          <a:xfrm>
-            <a:off x="1082040" y="1570000"/>
-            <a:ext cx="10200000" cy="450000"/>
-          </a:xfrm>
-          <a:prstGeom prst="rect">
-            <a:avLst/>
-          </a:prstGeom>
-          <a:noFill/>
-        </p:spPr>
-        <p:txBody>
-          <a:bodyPr wrap="square" lIns="0" rIns="0" tIns="0" bIns="0">
-            <a:spAutoFit/>
-          </a:bodyPr>
-          <a:lstStyle/>
-          <a:p>
-            <a:pPr algn="l">
-              <a:defRPr sz="1700" b="0">
-                <a:solidFill>
-                  <a:srgbClr val="5A6376"/>
-                </a:solidFill>
-                <a:latin typeface="Aptos"/>
-              </a:defRPr>
-            </a:pPr>
-            <a:r>
-              <a:t>The accented-ASR study can be a focused downstream validation, rather than a separate paper stitched onto the trajectory work.</a:t>
-            </a:r>
-          </a:p>
-        </p:txBody>
-      </p:sp>
-      <p:sp>
-        <p:nvSpPr>
-          <p:cNvPr id="6" name="Rounded Rectangle 5"/>
+          <p:cNvPr id="5" name="Rounded Rectangle 4"/>
           <p:cNvSpPr/>
           <p:nvPr/>
         </p:nvSpPr>
         <p:spPr>
           <a:xfrm>
-            <a:off x="1082040" y="2310000"/>
-            <a:ext cx="3240000" cy="3000000"/>
+            <a:off x="1082040" y="1990000"/>
+            <a:ext cx="10296144" cy="3350000"/>
           </a:xfrm>
           <a:prstGeom prst="roundRect">
             <a:avLst/>
@@ -5868,14 +4773,14 @@
       </p:sp>
       <p:sp>
         <p:nvSpPr>
-          <p:cNvPr id="7" name="Rectangle 6"/>
+          <p:cNvPr id="6" name="Rectangle 5"/>
           <p:cNvSpPr/>
           <p:nvPr/>
         </p:nvSpPr>
         <p:spPr>
           <a:xfrm>
-            <a:off x="1082040" y="2310000"/>
-            <a:ext cx="3240000" cy="85000"/>
+            <a:off x="1082040" y="1990000"/>
+            <a:ext cx="10296144" cy="85000"/>
           </a:xfrm>
           <a:prstGeom prst="rect">
             <a:avLst/>
@@ -5911,14 +4816,14 @@
       </p:sp>
       <p:sp>
         <p:nvSpPr>
-          <p:cNvPr id="8" name="TextBox 7"/>
+          <p:cNvPr id="7" name="TextBox 6"/>
           <p:cNvSpPr txBox="1"/>
           <p:nvPr/>
         </p:nvSpPr>
         <p:spPr>
           <a:xfrm>
-            <a:off x="1292040" y="2470000"/>
-            <a:ext cx="2820000" cy="310000"/>
+            <a:off x="1292040" y="2150000"/>
+            <a:ext cx="9876144" cy="310000"/>
           </a:xfrm>
           <a:prstGeom prst="rect">
             <a:avLst/>
@@ -5940,21 +4845,21 @@
               </a:defRPr>
             </a:pPr>
             <a:r>
-              <a:t>Question from pretraining</a:t>
-            </a:r>
-          </a:p>
-        </p:txBody>
-      </p:sp>
-      <p:sp>
-        <p:nvSpPr>
-          <p:cNvPr id="9" name="TextBox 8"/>
+              <a:t>Questions to keep</a:t>
+            </a:r>
+          </a:p>
+        </p:txBody>
+      </p:sp>
+      <p:sp>
+        <p:nvSpPr>
+          <p:cNvPr id="8" name="TextBox 7"/>
           <p:cNvSpPr txBox="1"/>
           <p:nvPr/>
         </p:nvSpPr>
         <p:spPr>
           <a:xfrm>
-            <a:off x="1292040" y="2900000"/>
-            <a:ext cx="2820000" cy="2240000"/>
+            <a:off x="1292040" y="2580000"/>
+            <a:ext cx="9876144" cy="2590000"/>
           </a:xfrm>
           <a:prstGeom prst="rect">
             <a:avLst/>
@@ -5979,393 +4884,19 @@
               </a:defRPr>
             </a:pPr>
             <a:r>
-              <a:t>• When does content, speaker, phonetic, or accent information emerge?</a:t>
+              <a:t>• Which information emerges during pretraining?</a:t>
             </a:r>
             <a:br/>
             <a:r>
-              <a:t>• Which layers change as SSL validation performance improves?</a:t>
+              <a:t>• Which layers retain content, speaker, and accent information?</a:t>
             </a:r>
             <a:br/>
             <a:r>
-              <a:t>• Do representation diagnostics forecast useful downstream behavior?</a:t>
-            </a:r>
-          </a:p>
-        </p:txBody>
-      </p:sp>
-      <p:sp>
-        <p:nvSpPr>
-          <p:cNvPr id="10" name="Rounded Rectangle 9"/>
-          <p:cNvSpPr/>
-          <p:nvPr/>
-        </p:nvSpPr>
-        <p:spPr>
-          <a:xfrm>
-            <a:off x="4570000" y="2310000"/>
-            <a:ext cx="3240000" cy="3000000"/>
-          </a:xfrm>
-          <a:prstGeom prst="roundRect">
-            <a:avLst/>
-          </a:prstGeom>
-          <a:solidFill>
-            <a:srgbClr val="F7F8FC"/>
-          </a:solidFill>
-          <a:ln w="10160">
-            <a:solidFill>
-              <a:srgbClr val="EEF1F8"/>
-            </a:solidFill>
-          </a:ln>
-        </p:spPr>
-        <p:style>
-          <a:lnRef idx="1">
-            <a:schemeClr val="accent1"/>
-          </a:lnRef>
-          <a:fillRef idx="3">
-            <a:schemeClr val="accent1"/>
-          </a:fillRef>
-          <a:effectRef idx="2">
-            <a:schemeClr val="accent1"/>
-          </a:effectRef>
-          <a:fontRef idx="minor">
-            <a:schemeClr val="lt1"/>
-          </a:fontRef>
-        </p:style>
-        <p:txBody>
-          <a:bodyPr rtlCol="0" anchor="ctr"/>
-          <a:lstStyle/>
-          <a:p>
-            <a:pPr algn="ctr"/>
-          </a:p>
-        </p:txBody>
-      </p:sp>
-      <p:sp>
-        <p:nvSpPr>
-          <p:cNvPr id="11" name="Rectangle 10"/>
-          <p:cNvSpPr/>
-          <p:nvPr/>
-        </p:nvSpPr>
-        <p:spPr>
-          <a:xfrm>
-            <a:off x="4570000" y="2310000"/>
-            <a:ext cx="3240000" cy="85000"/>
-          </a:xfrm>
-          <a:prstGeom prst="rect">
-            <a:avLst/>
-          </a:prstGeom>
-          <a:solidFill>
-            <a:srgbClr val="5A6376"/>
-          </a:solidFill>
-          <a:ln>
-            <a:noFill/>
-          </a:ln>
-        </p:spPr>
-        <p:style>
-          <a:lnRef idx="1">
-            <a:schemeClr val="accent1"/>
-          </a:lnRef>
-          <a:fillRef idx="3">
-            <a:schemeClr val="accent1"/>
-          </a:fillRef>
-          <a:effectRef idx="2">
-            <a:schemeClr val="accent1"/>
-          </a:effectRef>
-          <a:fontRef idx="minor">
-            <a:schemeClr val="lt1"/>
-          </a:fontRef>
-        </p:style>
-        <p:txBody>
-          <a:bodyPr rtlCol="0" anchor="ctr"/>
-          <a:lstStyle/>
-          <a:p>
-            <a:pPr algn="ctr"/>
-          </a:p>
-        </p:txBody>
-      </p:sp>
-      <p:sp>
-        <p:nvSpPr>
-          <p:cNvPr id="12" name="TextBox 11"/>
-          <p:cNvSpPr txBox="1"/>
-          <p:nvPr/>
-        </p:nvSpPr>
-        <p:spPr>
-          <a:xfrm>
-            <a:off x="4780000" y="2470000"/>
-            <a:ext cx="2820000" cy="310000"/>
-          </a:xfrm>
-          <a:prstGeom prst="rect">
-            <a:avLst/>
-          </a:prstGeom>
-          <a:noFill/>
-        </p:spPr>
-        <p:txBody>
-          <a:bodyPr wrap="square" lIns="0" rIns="0" tIns="0" bIns="0">
-            <a:spAutoFit/>
-          </a:bodyPr>
-          <a:lstStyle/>
-          <a:p>
-            <a:pPr algn="l">
-              <a:defRPr sz="1800" b="1">
-                <a:solidFill>
-                  <a:srgbClr val="1F2636"/>
-                </a:solidFill>
-                <a:latin typeface="Aptos"/>
-              </a:defRPr>
-            </a:pPr>
-            <a:r>
-              <a:t>Accented-ASR contribution</a:t>
-            </a:r>
-          </a:p>
-        </p:txBody>
-      </p:sp>
-      <p:sp>
-        <p:nvSpPr>
-          <p:cNvPr id="13" name="TextBox 12"/>
-          <p:cNvSpPr txBox="1"/>
-          <p:nvPr/>
-        </p:nvSpPr>
-        <p:spPr>
-          <a:xfrm>
-            <a:off x="4780000" y="2900000"/>
-            <a:ext cx="2820000" cy="2240000"/>
-          </a:xfrm>
-          <a:prstGeom prst="rect">
-            <a:avLst/>
-          </a:prstGeom>
-          <a:noFill/>
-        </p:spPr>
-        <p:txBody>
-          <a:bodyPr wrap="square" lIns="0" rIns="0" tIns="0" bIns="0">
-            <a:spAutoFit/>
-          </a:bodyPr>
-          <a:lstStyle/>
-          <a:p>
-            <a:pPr algn="l">
-              <a:spcAft>
-                <a:spcPts val="600"/>
-              </a:spcAft>
-              <a:defRPr sz="1500" b="0">
-                <a:solidFill>
-                  <a:srgbClr val="1F2636"/>
-                </a:solidFill>
-                <a:latin typeface="Aptos"/>
-              </a:defRPr>
-            </a:pPr>
-            <a:r>
-              <a:t>• A controlled task where content-aligned geometry is deliberately manipulated.</a:t>
+              <a:t>• Do representation metrics predict downstream ASR?</a:t>
             </a:r>
             <a:br/>
             <a:r>
-              <a:t>• A stress test for whether retrieval, probes, and similarity metrics track WER.</a:t>
-            </a:r>
-            <a:br/>
-            <a:r>
-              <a:t>• A setting with speaker and accent variation rather than only read-speech accuracy.</a:t>
-            </a:r>
-          </a:p>
-        </p:txBody>
-      </p:sp>
-      <p:sp>
-        <p:nvSpPr>
-          <p:cNvPr id="14" name="Rounded Rectangle 13"/>
-          <p:cNvSpPr/>
-          <p:nvPr/>
-        </p:nvSpPr>
-        <p:spPr>
-          <a:xfrm>
-            <a:off x="8060000" y="2310000"/>
-            <a:ext cx="3240000" cy="3000000"/>
-          </a:xfrm>
-          <a:prstGeom prst="roundRect">
-            <a:avLst/>
-          </a:prstGeom>
-          <a:solidFill>
-            <a:srgbClr val="F7F8FC"/>
-          </a:solidFill>
-          <a:ln w="10160">
-            <a:solidFill>
-              <a:srgbClr val="EEF1F8"/>
-            </a:solidFill>
-          </a:ln>
-        </p:spPr>
-        <p:style>
-          <a:lnRef idx="1">
-            <a:schemeClr val="accent1"/>
-          </a:lnRef>
-          <a:fillRef idx="3">
-            <a:schemeClr val="accent1"/>
-          </a:fillRef>
-          <a:effectRef idx="2">
-            <a:schemeClr val="accent1"/>
-          </a:effectRef>
-          <a:fontRef idx="minor">
-            <a:schemeClr val="lt1"/>
-          </a:fontRef>
-        </p:style>
-        <p:txBody>
-          <a:bodyPr rtlCol="0" anchor="ctr"/>
-          <a:lstStyle/>
-          <a:p>
-            <a:pPr algn="ctr"/>
-          </a:p>
-        </p:txBody>
-      </p:sp>
-      <p:sp>
-        <p:nvSpPr>
-          <p:cNvPr id="15" name="Rectangle 14"/>
-          <p:cNvSpPr/>
-          <p:nvPr/>
-        </p:nvSpPr>
-        <p:spPr>
-          <a:xfrm>
-            <a:off x="8060000" y="2310000"/>
-            <a:ext cx="3240000" cy="85000"/>
-          </a:xfrm>
-          <a:prstGeom prst="rect">
-            <a:avLst/>
-          </a:prstGeom>
-          <a:solidFill>
-            <a:srgbClr val="5A6376"/>
-          </a:solidFill>
-          <a:ln>
-            <a:noFill/>
-          </a:ln>
-        </p:spPr>
-        <p:style>
-          <a:lnRef idx="1">
-            <a:schemeClr val="accent1"/>
-          </a:lnRef>
-          <a:fillRef idx="3">
-            <a:schemeClr val="accent1"/>
-          </a:fillRef>
-          <a:effectRef idx="2">
-            <a:schemeClr val="accent1"/>
-          </a:effectRef>
-          <a:fontRef idx="minor">
-            <a:schemeClr val="lt1"/>
-          </a:fontRef>
-        </p:style>
-        <p:txBody>
-          <a:bodyPr rtlCol="0" anchor="ctr"/>
-          <a:lstStyle/>
-          <a:p>
-            <a:pPr algn="ctr"/>
-          </a:p>
-        </p:txBody>
-      </p:sp>
-      <p:sp>
-        <p:nvSpPr>
-          <p:cNvPr id="16" name="TextBox 15"/>
-          <p:cNvSpPr txBox="1"/>
-          <p:nvPr/>
-        </p:nvSpPr>
-        <p:spPr>
-          <a:xfrm>
-            <a:off x="8270000" y="2470000"/>
-            <a:ext cx="2820000" cy="310000"/>
-          </a:xfrm>
-          <a:prstGeom prst="rect">
-            <a:avLst/>
-          </a:prstGeom>
-          <a:noFill/>
-        </p:spPr>
-        <p:txBody>
-          <a:bodyPr wrap="square" lIns="0" rIns="0" tIns="0" bIns="0">
-            <a:spAutoFit/>
-          </a:bodyPr>
-          <a:lstStyle/>
-          <a:p>
-            <a:pPr algn="l">
-              <a:defRPr sz="1800" b="1">
-                <a:solidFill>
-                  <a:srgbClr val="1F2636"/>
-                </a:solidFill>
-                <a:latin typeface="Aptos"/>
-              </a:defRPr>
-            </a:pPr>
-            <a:r>
-              <a:t>Practical decision</a:t>
-            </a:r>
-          </a:p>
-        </p:txBody>
-      </p:sp>
-      <p:sp>
-        <p:nvSpPr>
-          <p:cNvPr id="17" name="TextBox 16"/>
-          <p:cNvSpPr txBox="1"/>
-          <p:nvPr/>
-        </p:nvSpPr>
-        <p:spPr>
-          <a:xfrm>
-            <a:off x="8270000" y="2900000"/>
-            <a:ext cx="2820000" cy="2240000"/>
-          </a:xfrm>
-          <a:prstGeom prst="rect">
-            <a:avLst/>
-          </a:prstGeom>
-          <a:noFill/>
-        </p:spPr>
-        <p:txBody>
-          <a:bodyPr wrap="square" lIns="0" rIns="0" tIns="0" bIns="0">
-            <a:spAutoFit/>
-          </a:bodyPr>
-          <a:lstStyle/>
-          <a:p>
-            <a:pPr algn="l">
-              <a:spcAft>
-                <a:spcPts val="600"/>
-              </a:spcAft>
-              <a:defRPr sz="1500" b="0">
-                <a:solidFill>
-                  <a:srgbClr val="1F2636"/>
-                </a:solidFill>
-                <a:latin typeface="Aptos"/>
-              </a:defRPr>
-            </a:pPr>
-            <a:r>
-              <a:t>• First finish the matched staged comparison and shuffled control.</a:t>
-            </a:r>
-            <a:br/>
-            <a:r>
-              <a:t>• Then use selected SSL checkpoints to test whether early diagnostics predict adaptation outcomes.</a:t>
-            </a:r>
-            <a:br/>
-            <a:r>
-              <a:t>• Keep claims descriptive unless checkpoint-level and seed-level evidence agrees.</a:t>
-            </a:r>
-          </a:p>
-        </p:txBody>
-      </p:sp>
-      <p:sp>
-        <p:nvSpPr>
-          <p:cNvPr id="18" name="TextBox 17"/>
-          <p:cNvSpPr txBox="1"/>
-          <p:nvPr/>
-        </p:nvSpPr>
-        <p:spPr>
-          <a:xfrm>
-            <a:off x="1350000" y="5800000"/>
-            <a:ext cx="9540000" cy="350000"/>
-          </a:xfrm>
-          <a:prstGeom prst="rect">
-            <a:avLst/>
-          </a:prstGeom>
-          <a:noFill/>
-        </p:spPr>
-        <p:txBody>
-          <a:bodyPr wrap="square" lIns="0" rIns="0" tIns="0" bIns="0">
-            <a:spAutoFit/>
-          </a:bodyPr>
-          <a:lstStyle/>
-          <a:p>
-            <a:pPr algn="ctr">
-              <a:defRPr sz="1800" b="1">
-                <a:solidFill>
-                  <a:srgbClr val="405294"/>
-                </a:solidFill>
-                <a:latin typeface="Aptos"/>
-              </a:defRPr>
-            </a:pPr>
-            <a:r>
-              <a:t>Target contribution: a layer-by-layer map of what changes during pretraining, plus evidence on which changes matter downstream.</a:t>
+              <a:t>• Use accented ASR as a controlled downstream test.</a:t>
             </a:r>
           </a:p>
         </p:txBody>

</xml_diff>